<commit_message>
LSA Climatology: Lessons 19-21 and Further Study 1 rewritten from the teacher's supports
Meaning of climate and Köppen's classification, tropical weather disturbances,
micro-climates and mountain climates rebuilt natively (v3n/lsaclim_1.js),
with Garoua and Mount Cameroon examples and short homework preparing the next
lesson. Further Study 3 (climate of Cameroon) is kept, with a new homework
leading into Hydrology. New diagrams in big_clim2.py.

Co-Authored-By: Claude Opus 5.5 <noreply@anthropic.com>
Claude-Session: https://claude.ai/code/session_0115LFSb2ktGLWPeVksFkSer
</commit_message>
<xml_diff>
--- a/lecons/LSA/Climatology/05_LSA_CLIM_FS03_The_Climate_of_Cameroon.pptx
+++ b/lecons/LSA/Climatology/05_LSA_CLIM_FS03_The_Climate_of_Cameroon.pptx
@@ -4784,7 +4784,7 @@
           <a:p>
             <a:r>
               <a:rPr lang="en-US" dirty="0"/>
-              <a:t>For your homework: Draw the climate map of Cameroon and write one town for each climate type. We shall correct it at the beginning of our next lesson.</a:t>
+              <a:t>For your homework: Define hydrology. We shall correct it at the beginning of our next lesson.</a:t>
             </a:r>
             <a:endParaRPr lang="en-US" dirty="0"/>
           </a:p>
@@ -19140,7 +19140,7 @@
                 <a:ea typeface="Times New Roman" pitchFamily="34" charset="-122"/>
                 <a:cs typeface="Times New Roman" pitchFamily="34" charset="-120"/>
               </a:rPr>
-              <a:t>Draw the climate map of Cameroon and write one town for each climate type.</a:t>
+              <a:t>Define hydrology.</a:t>
             </a:r>
             <a:endParaRPr lang="en-US" sz="4000" dirty="0"/>
           </a:p>
@@ -21804,7 +21804,7 @@
                           <a:ea typeface="Calibri" pitchFamily="34" charset="-122"/>
                           <a:cs typeface="Calibri" pitchFamily="34" charset="-120"/>
                         </a:rPr>
-                        <a:t>Draw the climate map of Cameroon and write one town for each climate type.</a:t>
+                        <a:t>Define hydrology.</a:t>
                       </a:r>
                       <a:endParaRPr lang="en-US" sz="1600" dirty="0">
                         <a:latin typeface="Calibri" charset="0"/>

</xml_diff>